<commit_message>
Add labeled 2000-present chart, slide, and view table
New chart_2000_present (value labels, legend moved clear of the data) and a
matching deck slide and view_2000_present.csv. Existing slides unchanged.

Co-Authored-By: Claude Opus 4.8 <noreply@anthropic.com>
</commit_message>
<xml_diff>
--- a/TPSNR_treecount_slides.pptx
+++ b/TPSNR_treecount_slides.pptx
@@ -11,6 +11,7 @@
     <p:sldId id="259" r:id="rId10"/>
     <p:sldId id="260" r:id="rId11"/>
     <p:sldId id="261" r:id="rId12"/>
+    <p:sldId id="262" r:id="rId13"/>
   </p:sldIdLst>
   <p:sldSz cx="12191695" cy="6858000" type="screen4x3"/>
   <p:notesSz cx="6858000" cy="9144000"/>
@@ -3569,6 +3570,116 @@
                 </a:solidFill>
                 <a:latin typeface="Arial"/>
               </a:rPr>
+              <a:t>2000 to present</a:t>
+            </a:r>
+          </a:p>
+        </p:txBody>
+      </p:sp>
+      <p:pic>
+        <p:nvPicPr>
+          <p:cNvPr id="3" name="Picture 2" descr="chart_2000_present.png"/>
+          <p:cNvPicPr>
+            <a:picLocks noChangeAspect="1"/>
+          </p:cNvPicPr>
+          <p:nvPr/>
+        </p:nvPicPr>
+        <p:blipFill>
+          <a:blip r:embed="rId2"/>
+          <a:stretch>
+            <a:fillRect/>
+          </a:stretch>
+        </p:blipFill>
+        <p:spPr>
+          <a:xfrm>
+            <a:off x="1280160" y="1188720"/>
+            <a:ext cx="9601200" cy="5399948"/>
+          </a:xfrm>
+          <a:prstGeom prst="rect">
+            <a:avLst/>
+          </a:prstGeom>
+        </p:spPr>
+      </p:pic>
+      <p:sp>
+        <p:nvSpPr>
+          <p:cNvPr id="4" name="TextBox 3"/>
+          <p:cNvSpPr txBox="1"/>
+          <p:nvPr/>
+        </p:nvSpPr>
+        <p:spPr>
+          <a:xfrm>
+            <a:off x="731520" y="5989320"/>
+            <a:ext cx="10698480" cy="731520"/>
+          </a:xfrm>
+          <a:prstGeom prst="rect">
+            <a:avLst/>
+          </a:prstGeom>
+          <a:noFill/>
+        </p:spPr>
+        <p:txBody>
+          <a:bodyPr wrap="square">
+            <a:spAutoFit/>
+          </a:bodyPr>
+          <a:lstStyle/>
+          <a:p>
+            <a:r>
+              <a:rPr sz="1200" b="0" i="1">
+                <a:solidFill>
+                  <a:srgbClr val="777777"/>
+                </a:solidFill>
+                <a:latin typeface="Arial"/>
+              </a:rPr>
+              <a:t>The last ~25 years with values labeled. A gentle decline from the 2000 estimate (5,000) through the 2006 and 2018 manual counts to the 2026 post-fire figure (3,950).</a:t>
+            </a:r>
+          </a:p>
+        </p:txBody>
+      </p:sp>
+    </p:spTree>
+  </p:cSld>
+  <p:clrMapOvr>
+    <a:masterClrMapping/>
+  </p:clrMapOvr>
+</p:sld>
+</file>
+
+<file path=ppt/slides/slide6.xml><?xml version="1.0" encoding="utf-8"?>
+<p:sld xmlns:a="http://schemas.openxmlformats.org/drawingml/2006/main" xmlns:p="http://schemas.openxmlformats.org/presentationml/2006/main" xmlns:r="http://schemas.openxmlformats.org/officeDocument/2006/relationships">
+  <p:cSld>
+    <p:spTree>
+      <p:nvGrpSpPr>
+        <p:cNvPr id="1" name=""/>
+        <p:cNvGrpSpPr/>
+        <p:nvPr/>
+      </p:nvGrpSpPr>
+      <p:grpSpPr/>
+      <p:sp>
+        <p:nvSpPr>
+          <p:cNvPr id="2" name="TextBox 1"/>
+          <p:cNvSpPr txBox="1"/>
+          <p:nvPr/>
+        </p:nvSpPr>
+        <p:spPr>
+          <a:xfrm>
+            <a:off x="548640" y="320040"/>
+            <a:ext cx="10972800" cy="731520"/>
+          </a:xfrm>
+          <a:prstGeom prst="rect">
+            <a:avLst/>
+          </a:prstGeom>
+          <a:noFill/>
+        </p:spPr>
+        <p:txBody>
+          <a:bodyPr wrap="square">
+            <a:spAutoFit/>
+          </a:bodyPr>
+          <a:lstStyle/>
+          <a:p>
+            <a:r>
+              <a:rPr sz="2600" b="1" i="0">
+                <a:solidFill>
+                  <a:srgbClr val="2E5A34"/>
+                </a:solidFill>
+                <a:latin typeface="Arial"/>
+              </a:rPr>
               <a:t>The data</a:t>
             </a:r>
           </a:p>
@@ -4899,7 +5010,7 @@
 </p:sld>
 </file>
 
-<file path=ppt/slides/slide6.xml><?xml version="1.0" encoding="utf-8"?>
+<file path=ppt/slides/slide7.xml><?xml version="1.0" encoding="utf-8"?>
 <p:sld xmlns:a="http://schemas.openxmlformats.org/drawingml/2006/main" xmlns:p="http://schemas.openxmlformats.org/presentationml/2006/main" xmlns:r="http://schemas.openxmlformats.org/officeDocument/2006/relationships">
   <p:cSld>
     <p:spTree>

</xml_diff>